<commit_message>
Gauntlet R1 build: L3 Hallucination Hunters — thumbnail-first cover, tick-box verdicts, plain editor note, second-source keys, what-ifs, deck fixes, listing per D2
Co-Authored-By: Claude Fable 5.1 <noreply@anthropic.com>
Claude-Session: https://claude.ai/code/session_01VWaJFc84eoA3U4f2VjTKjw
</commit_message>
<xml_diff>
--- a/products/ai-fact-check-lab/dist/Hallucination Hunters - Slides.pptx
+++ b/products/ai-fact-check-lab/dist/Hallucination Hunters - Slides.pptx
@@ -777,7 +777,7 @@
           <a:p>
             <a:r>
               <a:rPr lang="en-US" dirty="0"/>
-              <a:t>Close on this. Next in the unit: Teach AI Your Taste — using AI as an editor on your own writing without letting it take over.</a:t>
+              <a:t>Close on this. Next in the unit: Teach AI Your Taste (Lesson 4, sold separately) — using AI as an editor on your own writing without letting it take over.</a:t>
             </a:r>
             <a:endParaRPr lang="en-US" dirty="0"/>
           </a:p>
@@ -865,7 +865,7 @@
           <a:p>
             <a:r>
               <a:rPr lang="en-US" dirty="0"/>
-              <a:t>Read this aloud, smooth and confident, like a news anchor: "Our solar system has eight planets orbiting one star, the Sun. The closest planet to the Sun is Venus, which is also the hottest. Mars is called the Red Planet because rusty iron dust covers its surface. Saturn is famous for its rings — it is the only planet in our solar system that has them. Sunlight takes about eight minutes to reach Earth." Then ask for the vote: "This is going in tomorrow's paper. Print it?" Most classes vote print. Do NOT reveal yet — advance to the question slide.</a:t>
+              <a:t>Read this aloud, smooth and confident, like a news anchor: "Our solar system has eight planets orbiting one star, the Sun. The closest planet to the Sun is Venus, which is also the hottest. Mars is called the Red Planet because rusty iron dust covers its surface. Saturn is famous for its rings — it is the only planet in our solar system that has them. Sunlight takes about eight minutes to reach Earth." Then ask for the vote: "This is going in tomorrow's paper. Print it?" Most classes vote print. Do NOT reveal yet — advance to the question slide. If the room votes HOLD, ask which sentence they doubt — most name Saturn and miss Venus. If a kid names Venus instantly: "Hold that — write it down. We vote first, then we check."</a:t>
             </a:r>
             <a:endParaRPr lang="en-US" dirty="0"/>
           </a:p>
@@ -1041,7 +1041,7 @@
           <a:p>
             <a:r>
               <a:rPr lang="en-US" dirty="0"/>
-              <a:t>Why it happens (3 min). Say the quote, then the sub. Met the trickster genie in Lesson 1? Same trickster, new disguise.</a:t>
+              <a:t>Why it happens (3 min). Say the quote, then the sub. If your class did the genie lesson: same trickster, new disguise. If someone asks "so is AI always wrong?": "No — it's right a lot. That's what makes it dangerous: you can't tell by the tone. So we check."</a:t>
             </a:r>
             <a:endParaRPr lang="en-US" dirty="0"/>
           </a:p>
@@ -1393,7 +1393,7 @@
           <a:p>
             <a:r>
               <a:rPr lang="en-US" dirty="0"/>
-              <a:t>Deja's memo is on the worksheet: nothing runs until the desk clears it. Play the managing editor, not the answer key — when a desk asks "is this one true?", answer "that's a checkable claim — where's your second source?" Keep deadline energy: "Presses roll in five!" ANSWER KEY (notes only): #1 — first crewed Moon landing was 1969, not 1959; the Moon reflects sunlight, it makes none of its own. Verdict FIX. #2 — Everest is in the Himalayas in Asia, not the Andes; Australia's capital is Canberra, not Sydney. Verdict FIX. #3 — Alexander Graham Bell patented the telephone in 1876, not Edison; the Edison quote is fabricated for this exercise and has no source. Verdict KILL. No draft earns RUN today — tell the class that's realistic. Support: Drafts #1–2 only, hint "each draft hides exactly two problems."</a:t>
+              <a:t>Deja's note is at the top of the worksheet: no story gets printed until the desk checks it. Play the editor, not the answer key — when a desk asks "is this one true?", answer "that's a checkable claim — where's your second source?" Keep deadline energy: "Presses roll in five!" ANSWER KEY (notes only): #1 — first crewed Moon landing was 1969, not 1959 (pushback to expect: the uncrewed probe Luna 2 reached the Moon in 1959 — credit it, but "astronauts landed" is still false); the Moon reflects sunlight, it makes none of its own; its ending (brightest night-sky object) is true for the wrong reason. Verdict FIX. #2 — Everest is in the Himalayas in Asia, not the Andes; Australia's capital is Canberra, not Sydney; the three-continents ending no longer follows. Verdict FIX. #3 — Alexander Graham Bell patented the telephone in 1876, not Edison; the Edison quote is fabricated for this exercise and has no source. Verdict KILL. No draft earns RUN today — tell the class that's realistic. Call "Swap!" at the 7-minute mark of Round 2. Early finishers: the Extension — write a smooth passage with one planted error and trade. Support: Drafts #1–2 only, hint "each draft hides two false facts (plus a shaky ending)."</a:t>
             </a:r>
             <a:endParaRPr lang="en-US" dirty="0"/>
           </a:p>
@@ -1481,7 +1481,7 @@
           <a:p>
             <a:r>
               <a:rPr lang="en-US" dirty="0"/>
-              <a:t>Leave this up during both desk shifts. Watch for the two failure modes: the trusting desk clears everything ("it sounded right") — send them back to step 1; the paranoid desk kills everything ("it's all sus") — that's what RANK is for. Score the evidence, not the stamp.</a:t>
+              <a:t>Leave this up during both rounds. Watch for the two failure modes: the trusting desk clears everything ("it sounded right") — send them back to step 1; the paranoid desk kills everything ("it's all sus") — that's what RANK is for. Score the evidence, not the stamp.</a:t>
             </a:r>
             <a:endParaRPr lang="en-US" dirty="0"/>
           </a:p>
@@ -2067,7 +2067,7 @@
                 <a:ea typeface="Arial" pitchFamily="34" charset="-122"/>
                 <a:cs typeface="Arial" pitchFamily="34" charset="-120"/>
               </a:rPr>
-              <a:t>AI predicts likely words, not true ones — so it can be flat-out wrong in a totally confident voice. Today you're the fact desk: nothing runs until you clear it.</a:t>
+              <a:t>AI predicts likely words, not checked ones — so it can be completely wrong in a totally confident voice. Today you're the fact desk: nothing runs until you clear it.</a:t>
             </a:r>
             <a:endParaRPr lang="en-US" sz="1400" dirty="0"/>
           </a:p>
@@ -2214,7 +2214,7 @@
         <p:spPr>
           <a:xfrm>
             <a:off x="3204972" y="3977640"/>
-            <a:ext cx="1485900" cy="310896"/>
+            <a:ext cx="2418588" cy="310896"/>
           </a:xfrm>
           <a:prstGeom prst="roundRect">
             <a:avLst>
@@ -2241,7 +2241,7 @@
         <p:spPr>
           <a:xfrm>
             <a:off x="3204972" y="3977640"/>
-            <a:ext cx="1485900" cy="310896"/>
+            <a:ext cx="2418588" cy="310896"/>
           </a:xfrm>
           <a:prstGeom prst="rect">
             <a:avLst/>
@@ -2265,7 +2265,7 @@
                 <a:ea typeface="Arial" pitchFamily="34" charset="-122"/>
                 <a:cs typeface="Arial" pitchFamily="34" charset="-120"/>
               </a:rPr>
-              <a:t>Works unplugged</a:t>
+              <a:t>No prep · No devices needed</a:t>
             </a:r>
             <a:endParaRPr lang="en-US" sz="1000" dirty="0"/>
           </a:p>
@@ -2780,7 +2780,7 @@
                 <a:ea typeface="Arial" pitchFamily="34" charset="-122"/>
                 <a:cs typeface="Arial" pitchFamily="34" charset="-120"/>
               </a:rPr>
-              <a:t>Exit Ticket — Clock Out</a:t>
+              <a:t>Exit Ticket — Last Check</a:t>
             </a:r>
             <a:endParaRPr lang="en-US" sz="2600" dirty="0"/>
           </a:p>
@@ -2844,7 +2844,7 @@
                 <a:ea typeface="Arial" pitchFamily="34" charset="-122"/>
                 <a:cs typeface="Arial" pitchFamily="34" charset="-120"/>
               </a:rPr>
-              <a:t>2.  One claim you saw online this week — and the exact lateral-reading move you'd make on it.</a:t>
+              <a:t>2.  One claim you saw online this week — and a second source that is NOT where you first saw it.</a:t>
             </a:r>
             <a:endParaRPr lang="en-US" sz="1800" dirty="0"/>
           </a:p>
@@ -3233,7 +3233,7 @@
                 <a:ea typeface="Arial" pitchFamily="34" charset="-122"/>
                 <a:cs typeface="Arial" pitchFamily="34" charset="-120"/>
               </a:rPr>
-              <a:t>7 MIN</a:t>
+              <a:t>6 MIN</a:t>
             </a:r>
             <a:endParaRPr lang="en-US" sz="1000" dirty="0"/>
           </a:p>
@@ -3377,7 +3377,7 @@
                 <a:ea typeface="Arial" pitchFamily="34" charset="-122"/>
                 <a:cs typeface="Arial" pitchFamily="34" charset="-120"/>
               </a:rPr>
-              <a:t>Listen once, like an editor. No notes yet — just your gut.</a:t>
+              <a:t>Listen once, like an editor. No notes yet — just your first feeling.</a:t>
             </a:r>
             <a:endParaRPr lang="en-US" sz="1500" dirty="0"/>
           </a:p>
@@ -3443,7 +3443,7 @@
                 <a:ea typeface="Arial" pitchFamily="34" charset="-122"/>
                 <a:cs typeface="Arial" pitchFamily="34" charset="-120"/>
               </a:rPr>
-              <a:t>Vote:  PRINT IT  →  or  →  HOLD IT</a:t>
+              <a:t>Vote: PRINT IT / HOLD IT</a:t>
             </a:r>
             <a:endParaRPr lang="en-US" sz="1500" dirty="0"/>
           </a:p>
@@ -3658,7 +3658,7 @@
                 <a:ea typeface="Arial" pitchFamily="34" charset="-122"/>
                 <a:cs typeface="Arial" pitchFamily="34" charset="-120"/>
               </a:rPr>
-              <a:t>Two of those five claims were false.</a:t>
+              <a:t>Two of those sentences were false.</a:t>
             </a:r>
             <a:endParaRPr lang="en-US" sz="2600" dirty="0"/>
           </a:p>
@@ -4613,7 +4613,7 @@
               <a:buNone/>
             </a:pPr>
             <a:r>
-              <a:rPr lang="en-US" sz="1300" dirty="0">
+              <a:rPr lang="en-US" sz="1400" dirty="0">
                 <a:solidFill>
                   <a:srgbClr val="E8E8F5"/>
                 </a:solidFill>
@@ -4621,9 +4621,9 @@
                 <a:ea typeface="Arial" pitchFamily="34" charset="-122"/>
                 <a:cs typeface="Arial" pitchFamily="34" charset="-120"/>
               </a:rPr>
-              <a:t>Deadline reality: you can't check everything. Would hurt most if wrong? CHECK. Low-risk common knowledge? SAFE.</a:t>
-            </a:r>
-            <a:endParaRPr lang="en-US" sz="1300" dirty="0"/>
+              <a:t>You can't check everything. Would it hurt if wrong? Mark C. Everybody knows it? Mark S.</a:t>
+            </a:r>
+            <a:endParaRPr lang="en-US" sz="1400" dirty="0"/>
           </a:p>
         </p:txBody>
       </p:sp>
@@ -5721,7 +5721,7 @@
                 <a:ea typeface="Arial" pitchFamily="34" charset="-122"/>
                 <a:cs typeface="Arial" pitchFamily="34" charset="-120"/>
               </a:rPr>
-              <a:t>20 MIN</a:t>
+              <a:t>21 MIN</a:t>
             </a:r>
             <a:endParaRPr lang="en-US" sz="1000" dirty="0"/>
           </a:p>
@@ -5863,7 +5863,7 @@
                 <a:ea typeface="Arial" pitchFamily="34" charset="-122"/>
                 <a:cs typeface="Arial" pitchFamily="34" charset="-120"/>
               </a:rPr>
-              <a:t>Desk shift 1   ·   7 min</a:t>
+              <a:t>Round 1   ·   7 min</a:t>
             </a:r>
             <a:endParaRPr lang="en-US" sz="1500" dirty="0"/>
           </a:p>
@@ -5902,7 +5902,7 @@
                 <a:ea typeface="Arial" pitchFamily="34" charset="-122"/>
                 <a:cs typeface="Arial" pitchFamily="34" charset="-120"/>
               </a:rPr>
-              <a:t>Partners work Draft #1 (Priya's Moon column) together: underline, mark C or S, log where you'd verify, stamp a verdict with evidence.</a:t>
+              <a:t>Partners work Draft #1 (Priya's Moon column) together: underline, mark C or S, log where you'd check, tick a verdict, write the note.</a:t>
             </a:r>
             <a:endParaRPr lang="en-US" sz="1300" dirty="0"/>
           </a:p>
@@ -6005,7 +6005,7 @@
                 <a:ea typeface="Arial" pitchFamily="34" charset="-122"/>
                 <a:cs typeface="Arial" pitchFamily="34" charset="-120"/>
               </a:rPr>
-              <a:t>Desk shift 2   ·   9 min</a:t>
+              <a:t>Round 2   ·   10 min</a:t>
             </a:r>
             <a:endParaRPr lang="en-US" sz="1500" dirty="0"/>
           </a:p>
@@ -6044,7 +6044,7 @@
                 <a:ea typeface="Arial" pitchFamily="34" charset="-122"/>
                 <a:cs typeface="Arial" pitchFamily="34" charset="-120"/>
               </a:rPr>
-              <a:t>One partner leads Draft #2 (Theo's geography quiz), the other Draft #3 (Marcus's invention feature). Swap and double-check before stamping.</a:t>
+              <a:t>One partner leads Draft #2 (Theo's quiz page), the other Draft #3 (Marcus's invention feature). At "Swap!" double-check each other before you tick.</a:t>
             </a:r>
             <a:endParaRPr lang="en-US" sz="1300" dirty="0"/>
           </a:p>
@@ -6147,7 +6147,7 @@
                 <a:ea typeface="Arial" pitchFamily="34" charset="-122"/>
                 <a:cs typeface="Arial" pitchFamily="34" charset="-120"/>
               </a:rPr>
-              <a:t>Verdict stand-up   ·   4 min</a:t>
+              <a:t>Verdicts out loud   ·   4 min</a:t>
             </a:r>
             <a:endParaRPr lang="en-US" sz="1500" dirty="0"/>
           </a:p>
@@ -6462,7 +6462,7 @@
                 <a:ea typeface="Arial" pitchFamily="34" charset="-122"/>
                 <a:cs typeface="Arial" pitchFamily="34" charset="-120"/>
               </a:rPr>
-              <a:t>Back every stamp with evidence: the claim, the correction, the second source.</a:t>
+              <a:t>Back every stamp with evidence: the claim, the fix, the second source.</a:t>
             </a:r>
             <a:endParaRPr lang="en-US" sz="1800" dirty="0"/>
           </a:p>

</xml_diff>

<commit_message>
Gauntlet R2 fixes: L1 exit timing 3/7 + real-evaluation wording, L2 one-vibe playlist + answers off slide 9 + Training Data kicker, L3 stamp gloss + Edison antecedent + one-of verdict groups; print-media spills trimmed; tick → check
Co-Authored-By: Claude Fable 5.1 <noreply@anthropic.com>
Claude-Session: https://claude.ai/code/session_01VWaJFc84eoA3U4f2VjTKjw
</commit_message>
<xml_diff>
--- a/products/ai-fact-check-lab/dist/Hallucination Hunters - Slides.pptx
+++ b/products/ai-fact-check-lab/dist/Hallucination Hunters - Slides.pptx
@@ -2133,7 +2133,7 @@
                 <a:ea typeface="Arial" pitchFamily="34" charset="-122"/>
                 <a:cs typeface="Arial" pitchFamily="34" charset="-120"/>
               </a:rPr>
-              <a:t>Grades 6-8</a:t>
+              <a:t>Grades 6–8</a:t>
             </a:r>
             <a:endParaRPr lang="en-US" sz="1000" dirty="0"/>
           </a:p>
@@ -2844,7 +2844,7 @@
                 <a:ea typeface="Arial" pitchFamily="34" charset="-122"/>
                 <a:cs typeface="Arial" pitchFamily="34" charset="-120"/>
               </a:rPr>
-              <a:t>2.  One claim you saw online this week — and a second source that is NOT where you first saw it.</a:t>
+              <a:t>2.  A claim you saw online this week — or one you expect to see — and a second source NOT where you saw it.</a:t>
             </a:r>
             <a:endParaRPr lang="en-US" sz="1800" dirty="0"/>
           </a:p>
@@ -5506,7 +5506,7 @@
                 <a:ea typeface="Arial" pitchFamily="34" charset="-122"/>
                 <a:cs typeface="Arial" pitchFamily="34" charset="-120"/>
               </a:rPr>
-              <a:t>Don't ask the suspect if he's innocent.</a:t>
+              <a:t>Don't ask the suspect if they're innocent.</a:t>
             </a:r>
             <a:endParaRPr lang="en-US" sz="2800" dirty="0"/>
           </a:p>
@@ -5902,7 +5902,7 @@
                 <a:ea typeface="Arial" pitchFamily="34" charset="-122"/>
                 <a:cs typeface="Arial" pitchFamily="34" charset="-120"/>
               </a:rPr>
-              <a:t>Partners work Draft #1 (Priya's Moon column) together: underline, mark C or S, log where you'd check, tick a verdict, write the note.</a:t>
+              <a:t>Partners work Draft #1 (Priya's Moon column) together: underline, mark C or S, log where you'd check, check a verdict box, write the note.</a:t>
             </a:r>
             <a:endParaRPr lang="en-US" sz="1300" dirty="0"/>
           </a:p>
@@ -6186,7 +6186,7 @@
                 <a:ea typeface="Arial" pitchFamily="34" charset="-122"/>
                 <a:cs typeface="Arial" pitchFamily="34" charset="-120"/>
               </a:rPr>
-              <a:t>Each desk announces one verdict plus its best evidence. We tally RUN / FIX / KILL on the board and argue out disagreements.</a:t>
+              <a:t>Per draft, one desk per stamp announces its verdict plus its best evidence. Everyone else adds a tally mark on the board.</a:t>
             </a:r>
             <a:endParaRPr lang="en-US" sz="1300" dirty="0"/>
           </a:p>

</xml_diff>